<commit_message>
CL3 delivery Step 5: website practice baseline (open improvement) + EX rewording
Adds delivery/practice-lab-pack/ (baseline.yaml + README + .cfnlintrc) — the CL3
practice deploy artefact, modelled on the proven Ledgerline AT3 baseline, adapted
for the public MySQL website (internet-facing ALB, Linux, single-AZ, same
region-substitution patterns; cfn-lint clean; no improved.yaml — students apply
their own improvement). Rewords the topic_02 + topic_07 practice EX slides so the
website improvement is OPEN (Multi-AZ DB a valid choice — the Ledgerline
single-instance constraint does not apply); decks 02 + 07 rebuilt + size-gated.

Co-Authored-By: Claude Opus 4.8 (1M context) <noreply@anthropic.com>
</commit_message>
<xml_diff>
--- a/S1-CL3-Cloud-Infrastructure-Improvement/delivery/topic_02/Topic_02_Slides.pptx
+++ b/S1-CL3-Cloud-Infrastructure-Improvement/delivery/topic_02/Topic_02_Slides.pptx
@@ -3472,7 +3472,7 @@
                 </a:solidFill>
                 <a:latin typeface="Roboto"/>
               </a:rPr>
-              <a:t>For the practice vehicle, design the reliability improvements to the Topic-1 goals: app-tier Multi-AZ, DB backup/restore, cross-Region DR.</a:t>
+              <a:t>For the practice vehicle (the website), design the reliability improvements to the Topic-1 goals across the app, data and DR tiers — you decide what each tier needs, to the goals and no further.</a:t>
             </a:r>
           </a:p>
           <a:p>
@@ -3503,7 +3503,7 @@
                 </a:solidFill>
                 <a:latin typeface="Roboto"/>
               </a:rPr>
-              <a:t>Argue ONE cost-benefit trade-off explicitly (the Multi-AZ-database rejection is the model) and show how each change meets a named goal.</a:t>
+              <a:t>Argue ONE cost-benefit trade-off explicitly and show how each change meets a named goal. NB the website runs MySQL with no legacy single-instance constraint, so the data-tier call (e.g. whether to go Multi-AZ) is yours to justify — potentially the OPPOSITE call to Ledgerline's, reached by the same cost-benefit reasoning.</a:t>
             </a:r>
           </a:p>
         </p:txBody>

</xml_diff>